<commit_message>
bids: TAMU Wehner SSC-2025-06871 finishing pass -- apply_firm_profile + render
Co-authored-by: Cursor <cursoragent@cursor.com>
</commit_message>
<xml_diff>
--- a/bids/tamu-wehner-fin-340E-2025-06871/proposal/exports/tamu-wehner-fin-340E-2025-06871-pitch-deck.pptx
+++ b/bids/tamu-wehner-fin-340E-2025-06871/proposal/exports/tamu-wehner-fin-340E-2025-06871-pitch-deck.pptx
@@ -3422,7 +3422,7 @@
                 </a:solidFill>
                 <a:latin typeface="Calibri"/>
               </a:rPr>
-              <a:t>Submission date __________   ·   Document prepared 2026-05-27</a:t>
+              <a:t>Submission date __________   ·   Document prepared 2026-05-28</a:t>
             </a:r>
           </a:p>
         </p:txBody>
@@ -4148,7 +4148,7 @@
                 </a:solidFill>
                 <a:latin typeface="Calibri"/>
               </a:rPr>
-              <a:t>Bid tamu-wehner-fin-340E-2025-06871   ·   2026-05-27</a:t>
+              <a:t>Bid tamu-wehner-fin-340E-2025-06871   ·   2026-05-28</a:t>
             </a:r>
           </a:p>
         </p:txBody>

</xml_diff>